<commit_message>
Cập nhật báo cáo và slide theo kết quả kiểm thử cuối 55/55
- Chương 4: lần chạy cuối đạt 55/55 ca; năm lỗi TC-13, 18, 26, 37, 44 ghi rõ cách khắc phục;
  bảng đối chiếu: 32/33 FR đạt (còn FR-03), NFR-06 đạt; cập nhật hạn chế và hướng phát triển
- Chương 2: thêm BR-11 (thời hạn mượn tối đa 30 ngày), cập nhật cột kiểm thử của các use case
- Kết quả kiểm thử chức năng (functional_a, functional_b) của lần chạy cuối
- Slide 8, 14, 16, 18 và ghi chú thuyết trình theo kết quả mới
</commit_message>
<xml_diff>
--- a/BaoCao/SlideThuyetTrinh_FahasaDigital.pptx
+++ b/BaoCao/SlideThuyetTrinh_FahasaDigital.pptx
@@ -213,7 +213,7 @@
             </a:lvl1pPr>
           </a:lstStyle>
           <a:p>
-            <a:fld id="{C4E398BB-4C71-47CC-92A8-4F8F9643D713}" type="datetimeFigureOut">
+            <a:fld id="{71806824-9829-4E19-BD76-5BFCF0BE60E9}" type="datetimeFigureOut">
               <a:rPr lang="en-GB" smtClean="0"/>
               <a:t>26/10/2026</a:t>
             </a:fld>
@@ -372,7 +372,7 @@
             </a:lvl1pPr>
           </a:lstStyle>
           <a:p>
-            <a:fld id="{AEEF2A5A-C802-40EB-AFC1-120433C5638E}" type="slidenum">
+            <a:fld id="{51E82CE5-2603-479C-AEDC-E30E28585A01}" type="slidenum">
               <a:rPr lang="en-GB" smtClean="0"/>
               <a:t>‹#›</a:t>
             </a:fld>
@@ -383,7 +383,7 @@
     </p:spTree>
     <p:extLst>
       <p:ext uri="{BB962C8B-B14F-4D97-AF65-F5344CB8AC3E}">
-        <p14:creationId xmlns:p14="http://schemas.microsoft.com/office/powerpoint/2010/main" val="337562827"/>
+        <p14:creationId xmlns:p14="http://schemas.microsoft.com/office/powerpoint/2010/main" val="2059719858"/>
       </p:ext>
     </p:extLst>
   </p:cSld>
@@ -550,7 +550,7 @@
           <a:bodyPr/>
           <a:lstStyle/>
           <a:p>
-            <a:fld id="{AEEF2A5A-C802-40EB-AFC1-120433C5638E}" type="slidenum">
+            <a:fld id="{51E82CE5-2603-479C-AEDC-E30E28585A01}" type="slidenum">
               <a:rPr lang="en-GB" smtClean="0"/>
               <a:t>1</a:t>
             </a:fld>
@@ -561,7 +561,7 @@
     </p:spTree>
     <p:extLst>
       <p:ext uri="{BB962C8B-B14F-4D97-AF65-F5344CB8AC3E}">
-        <p14:creationId xmlns:p14="http://schemas.microsoft.com/office/powerpoint/2010/main" val="3871955853"/>
+        <p14:creationId xmlns:p14="http://schemas.microsoft.com/office/powerpoint/2010/main" val="2944375903"/>
       </p:ext>
     </p:extLst>
   </p:cSld>
@@ -638,7 +638,7 @@
           <a:bodyPr/>
           <a:lstStyle/>
           <a:p>
-            <a:fld id="{AEEF2A5A-C802-40EB-AFC1-120433C5638E}" type="slidenum">
+            <a:fld id="{51E82CE5-2603-479C-AEDC-E30E28585A01}" type="slidenum">
               <a:rPr lang="en-GB" smtClean="0"/>
               <a:t>10</a:t>
             </a:fld>
@@ -649,7 +649,7 @@
     </p:spTree>
     <p:extLst>
       <p:ext uri="{BB962C8B-B14F-4D97-AF65-F5344CB8AC3E}">
-        <p14:creationId xmlns:p14="http://schemas.microsoft.com/office/powerpoint/2010/main" val="2036367456"/>
+        <p14:creationId xmlns:p14="http://schemas.microsoft.com/office/powerpoint/2010/main" val="4006776250"/>
       </p:ext>
     </p:extLst>
   </p:cSld>
@@ -726,7 +726,7 @@
           <a:bodyPr/>
           <a:lstStyle/>
           <a:p>
-            <a:fld id="{AEEF2A5A-C802-40EB-AFC1-120433C5638E}" type="slidenum">
+            <a:fld id="{51E82CE5-2603-479C-AEDC-E30E28585A01}" type="slidenum">
               <a:rPr lang="en-GB" smtClean="0"/>
               <a:t>11</a:t>
             </a:fld>
@@ -737,7 +737,7 @@
     </p:spTree>
     <p:extLst>
       <p:ext uri="{BB962C8B-B14F-4D97-AF65-F5344CB8AC3E}">
-        <p14:creationId xmlns:p14="http://schemas.microsoft.com/office/powerpoint/2010/main" val="282722856"/>
+        <p14:creationId xmlns:p14="http://schemas.microsoft.com/office/powerpoint/2010/main" val="1015465638"/>
       </p:ext>
     </p:extLst>
   </p:cSld>
@@ -814,7 +814,7 @@
           <a:bodyPr/>
           <a:lstStyle/>
           <a:p>
-            <a:fld id="{AEEF2A5A-C802-40EB-AFC1-120433C5638E}" type="slidenum">
+            <a:fld id="{51E82CE5-2603-479C-AEDC-E30E28585A01}" type="slidenum">
               <a:rPr lang="en-GB" smtClean="0"/>
               <a:t>12</a:t>
             </a:fld>
@@ -825,7 +825,7 @@
     </p:spTree>
     <p:extLst>
       <p:ext uri="{BB962C8B-B14F-4D97-AF65-F5344CB8AC3E}">
-        <p14:creationId xmlns:p14="http://schemas.microsoft.com/office/powerpoint/2010/main" val="1348407777"/>
+        <p14:creationId xmlns:p14="http://schemas.microsoft.com/office/powerpoint/2010/main" val="3549394420"/>
       </p:ext>
     </p:extLst>
   </p:cSld>
@@ -902,7 +902,7 @@
           <a:bodyPr/>
           <a:lstStyle/>
           <a:p>
-            <a:fld id="{AEEF2A5A-C802-40EB-AFC1-120433C5638E}" type="slidenum">
+            <a:fld id="{51E82CE5-2603-479C-AEDC-E30E28585A01}" type="slidenum">
               <a:rPr lang="en-GB" smtClean="0"/>
               <a:t>13</a:t>
             </a:fld>
@@ -913,7 +913,7 @@
     </p:spTree>
     <p:extLst>
       <p:ext uri="{BB962C8B-B14F-4D97-AF65-F5344CB8AC3E}">
-        <p14:creationId xmlns:p14="http://schemas.microsoft.com/office/powerpoint/2010/main" val="1227350721"/>
+        <p14:creationId xmlns:p14="http://schemas.microsoft.com/office/powerpoint/2010/main" val="736742502"/>
       </p:ext>
     </p:extLst>
   </p:cSld>
@@ -969,7 +969,7 @@
           <a:p>
             <a:r>
               <a:rPr lang="vi-VN"/>
-              <a:t>Em kiểm thử bằng ba cách. Kiểm thử chức năng hộp đen: 55 ca, gọi API như một ứng dụng thật, gồm cả trường hợp hợp lệ và ngoại lệ, phủ 22 trên 33 yêu cầu chức năng. Rà soát bảo mật bằng phân tích mã nguồn tĩnh, đối chiếu OWASP Top 10 năm 2025; em không thực hiện tấn công khai thác. Kiểm thử hiệu năng: API tra cứu sách có trung vị 95 mili giây, phân vị 95 là 151 mili giây với 20 kết nối đồng thời; trợ lý AI phản hồi khoảng 1,7 giây. Lần chạy đầu đạt 48 trên 55 ca; sau khi khắc phục lỗi quá hạn, chạy lại đạt 50 trên 55. Năm ca còn lại em trình bày ở phần hạn chế.</a:t>
+              <a:t>Em kiểm thử bằng ba cách. Kiểm thử chức năng hộp đen: 55 ca, gọi API như một ứng dụng thật, gồm cả trường hợp hợp lệ và ngoại lệ, phủ 22 trên 33 yêu cầu chức năng. Rà soát bảo mật bằng phân tích mã nguồn tĩnh, đối chiếu OWASP Top 10 năm 2025; em không thực hiện tấn công khai thác. Kiểm thử hiệu năng: API tra cứu sách có trung vị 95 mili giây, phân vị 95 là 151 mili giây với 20 kết nối đồng thời; trợ lý AI phản hồi khoảng 1,7 giây. Lần chạy đầu đạt 48 trên 55 ca; sau khi khắc phục lỗi quá hạn đạt 50 trên 55; em sửa tiếp năm lỗi còn lại và lần chạy cuối đạt cả 55 trên 55.</a:t>
             </a:r>
             <a:endParaRPr lang="en-GB"/>
           </a:p>
@@ -990,7 +990,7 @@
           <a:bodyPr/>
           <a:lstStyle/>
           <a:p>
-            <a:fld id="{AEEF2A5A-C802-40EB-AFC1-120433C5638E}" type="slidenum">
+            <a:fld id="{51E82CE5-2603-479C-AEDC-E30E28585A01}" type="slidenum">
               <a:rPr lang="en-GB" smtClean="0"/>
               <a:t>14</a:t>
             </a:fld>
@@ -1001,7 +1001,7 @@
     </p:spTree>
     <p:extLst>
       <p:ext uri="{BB962C8B-B14F-4D97-AF65-F5344CB8AC3E}">
-        <p14:creationId xmlns:p14="http://schemas.microsoft.com/office/powerpoint/2010/main" val="2229784724"/>
+        <p14:creationId xmlns:p14="http://schemas.microsoft.com/office/powerpoint/2010/main" val="732420916"/>
       </p:ext>
     </p:extLst>
   </p:cSld>
@@ -1078,7 +1078,7 @@
           <a:bodyPr/>
           <a:lstStyle/>
           <a:p>
-            <a:fld id="{AEEF2A5A-C802-40EB-AFC1-120433C5638E}" type="slidenum">
+            <a:fld id="{51E82CE5-2603-479C-AEDC-E30E28585A01}" type="slidenum">
               <a:rPr lang="en-GB" smtClean="0"/>
               <a:t>15</a:t>
             </a:fld>
@@ -1089,7 +1089,7 @@
     </p:spTree>
     <p:extLst>
       <p:ext uri="{BB962C8B-B14F-4D97-AF65-F5344CB8AC3E}">
-        <p14:creationId xmlns:p14="http://schemas.microsoft.com/office/powerpoint/2010/main" val="3292660692"/>
+        <p14:creationId xmlns:p14="http://schemas.microsoft.com/office/powerpoint/2010/main" val="3931857055"/>
       </p:ext>
     </p:extLst>
   </p:cSld>
@@ -1145,7 +1145,7 @@
           <a:p>
             <a:r>
               <a:rPr lang="vi-VN"/>
-              <a:t>Những hạn chế còn lại. Bên trái là năm ca kiểm thử chưa đạt, đều là lỗi cài đặt nhỏ và có hướng khắc phục rõ: đổi middleware để chỉ quản trị viên đọc cấu hình; mặc định lọc sách ẩn ở API công khai; giới hạn thời hạn mượn phía máy chủ; đánh dấu đặt trước hoàn tất khi người chờ đã mượn; cập nhật số bản mất và hỏng khi trả. Bên phải là phạm vi: giao diện chưa có nút đăng nhập Google và trang quên mật khẩu, dù máy chủ đã có API; hệ thống mới chạy cục bộ, chưa có HTTPS, thanh toán ở môi trường sandbox; và em chưa có kiểm thử tự động cho giao diện, chưa thử trên Firefox và điện thoại.</a:t>
+              <a:t>Bên trái là năm lỗi mà bộ kiểm thử phát hiện, em đã khắc phục cả năm và chạy lại đạt 55 trên 55: chỉ quản trị viên được truy cập cấu hình; API công khai luôn ẩn sách bị ẩn, trang quản trị dùng API riêng; thời hạn mượn tối đa 30 ngày; đặt trước chuyển hoàn tất khi người chờ đã mượn; cập nhật số bản mất và hỏng khi trả. Bên phải là phạm vi: giao diện chưa có nút đăng nhập Google và trang quên mật khẩu, dù máy chủ đã có API; hệ thống mới chạy cục bộ, chưa có HTTPS, thanh toán ở môi trường sandbox; và em chưa có kiểm thử tự động cho giao diện, chưa thử trên Firefox và điện thoại; ngày mượn trong quá khứ mới được chặn ở giao diện.</a:t>
             </a:r>
             <a:endParaRPr lang="en-GB"/>
           </a:p>
@@ -1166,7 +1166,7 @@
           <a:bodyPr/>
           <a:lstStyle/>
           <a:p>
-            <a:fld id="{AEEF2A5A-C802-40EB-AFC1-120433C5638E}" type="slidenum">
+            <a:fld id="{51E82CE5-2603-479C-AEDC-E30E28585A01}" type="slidenum">
               <a:rPr lang="en-GB" smtClean="0"/>
               <a:t>16</a:t>
             </a:fld>
@@ -1177,7 +1177,7 @@
     </p:spTree>
     <p:extLst>
       <p:ext uri="{BB962C8B-B14F-4D97-AF65-F5344CB8AC3E}">
-        <p14:creationId xmlns:p14="http://schemas.microsoft.com/office/powerpoint/2010/main" val="3442362793"/>
+        <p14:creationId xmlns:p14="http://schemas.microsoft.com/office/powerpoint/2010/main" val="2647335729"/>
       </p:ext>
     </p:extLst>
   </p:cSld>
@@ -1254,7 +1254,7 @@
           <a:bodyPr/>
           <a:lstStyle/>
           <a:p>
-            <a:fld id="{AEEF2A5A-C802-40EB-AFC1-120433C5638E}" type="slidenum">
+            <a:fld id="{51E82CE5-2603-479C-AEDC-E30E28585A01}" type="slidenum">
               <a:rPr lang="en-GB" smtClean="0"/>
               <a:t>17</a:t>
             </a:fld>
@@ -1265,7 +1265,7 @@
     </p:spTree>
     <p:extLst>
       <p:ext uri="{BB962C8B-B14F-4D97-AF65-F5344CB8AC3E}">
-        <p14:creationId xmlns:p14="http://schemas.microsoft.com/office/powerpoint/2010/main" val="1729991874"/>
+        <p14:creationId xmlns:p14="http://schemas.microsoft.com/office/powerpoint/2010/main" val="411938254"/>
       </p:ext>
     </p:extLst>
   </p:cSld>
@@ -1321,7 +1321,7 @@
           <a:p>
             <a:r>
               <a:rPr lang="vi-VN"/>
-              <a:t>Tóm lại, em đã xây dựng được hệ thống web số hóa trọn vòng đời mượn – trả cho nhà sách, có đặc tả và truy vết từ vấn đề tới kiểm thử, đạt 50 trên 55 ca kiểm thử chức năng, và đã phát hiện, khắc phục sáu khiếm khuyết bảo mật. Hướng tiếp theo: sửa năm lỗi còn lại, bổ sung giao diện đăng nhập Google và trang quên mật khẩu, thêm kiểm thử tự động cho giao diện cùng CI, rồi triển khai thật với HTTPS và cổng thanh toán thật.</a:t>
+              <a:t>Tóm lại, em đã xây dựng được hệ thống web số hóa trọn vòng đời mượn – trả cho nhà sách, có đặc tả và truy vết từ vấn đề tới kiểm thử, đạt cả 55 trên 55 ca kiểm thử chức năng, và đã phát hiện, khắc phục sáu khiếm khuyết bảo mật cùng năm lỗi nghiệp vụ. Hướng tiếp theo: bổ sung giao diện đăng nhập Google và trang quên mật khẩu, thêm kiểm thử tự động cho giao diện cùng CI, rồi triển khai thật với HTTPS và cổng thanh toán thật.</a:t>
             </a:r>
             <a:endParaRPr lang="en-GB"/>
           </a:p>
@@ -1342,7 +1342,7 @@
           <a:bodyPr/>
           <a:lstStyle/>
           <a:p>
-            <a:fld id="{AEEF2A5A-C802-40EB-AFC1-120433C5638E}" type="slidenum">
+            <a:fld id="{51E82CE5-2603-479C-AEDC-E30E28585A01}" type="slidenum">
               <a:rPr lang="en-GB" smtClean="0"/>
               <a:t>18</a:t>
             </a:fld>
@@ -1353,7 +1353,7 @@
     </p:spTree>
     <p:extLst>
       <p:ext uri="{BB962C8B-B14F-4D97-AF65-F5344CB8AC3E}">
-        <p14:creationId xmlns:p14="http://schemas.microsoft.com/office/powerpoint/2010/main" val="1771956127"/>
+        <p14:creationId xmlns:p14="http://schemas.microsoft.com/office/powerpoint/2010/main" val="1830386098"/>
       </p:ext>
     </p:extLst>
   </p:cSld>
@@ -1430,7 +1430,7 @@
           <a:bodyPr/>
           <a:lstStyle/>
           <a:p>
-            <a:fld id="{AEEF2A5A-C802-40EB-AFC1-120433C5638E}" type="slidenum">
+            <a:fld id="{51E82CE5-2603-479C-AEDC-E30E28585A01}" type="slidenum">
               <a:rPr lang="en-GB" smtClean="0"/>
               <a:t>19</a:t>
             </a:fld>
@@ -1441,7 +1441,7 @@
     </p:spTree>
     <p:extLst>
       <p:ext uri="{BB962C8B-B14F-4D97-AF65-F5344CB8AC3E}">
-        <p14:creationId xmlns:p14="http://schemas.microsoft.com/office/powerpoint/2010/main" val="730897408"/>
+        <p14:creationId xmlns:p14="http://schemas.microsoft.com/office/powerpoint/2010/main" val="3588631288"/>
       </p:ext>
     </p:extLst>
   </p:cSld>
@@ -1518,7 +1518,7 @@
           <a:bodyPr/>
           <a:lstStyle/>
           <a:p>
-            <a:fld id="{AEEF2A5A-C802-40EB-AFC1-120433C5638E}" type="slidenum">
+            <a:fld id="{51E82CE5-2603-479C-AEDC-E30E28585A01}" type="slidenum">
               <a:rPr lang="en-GB" smtClean="0"/>
               <a:t>2</a:t>
             </a:fld>
@@ -1529,7 +1529,7 @@
     </p:spTree>
     <p:extLst>
       <p:ext uri="{BB962C8B-B14F-4D97-AF65-F5344CB8AC3E}">
-        <p14:creationId xmlns:p14="http://schemas.microsoft.com/office/powerpoint/2010/main" val="3988379926"/>
+        <p14:creationId xmlns:p14="http://schemas.microsoft.com/office/powerpoint/2010/main" val="251675609"/>
       </p:ext>
     </p:extLst>
   </p:cSld>
@@ -1606,7 +1606,7 @@
           <a:bodyPr/>
           <a:lstStyle/>
           <a:p>
-            <a:fld id="{AEEF2A5A-C802-40EB-AFC1-120433C5638E}" type="slidenum">
+            <a:fld id="{51E82CE5-2603-479C-AEDC-E30E28585A01}" type="slidenum">
               <a:rPr lang="en-GB" smtClean="0"/>
               <a:t>3</a:t>
             </a:fld>
@@ -1617,7 +1617,7 @@
     </p:spTree>
     <p:extLst>
       <p:ext uri="{BB962C8B-B14F-4D97-AF65-F5344CB8AC3E}">
-        <p14:creationId xmlns:p14="http://schemas.microsoft.com/office/powerpoint/2010/main" val="893494172"/>
+        <p14:creationId xmlns:p14="http://schemas.microsoft.com/office/powerpoint/2010/main" val="527678006"/>
       </p:ext>
     </p:extLst>
   </p:cSld>
@@ -1694,7 +1694,7 @@
           <a:bodyPr/>
           <a:lstStyle/>
           <a:p>
-            <a:fld id="{AEEF2A5A-C802-40EB-AFC1-120433C5638E}" type="slidenum">
+            <a:fld id="{51E82CE5-2603-479C-AEDC-E30E28585A01}" type="slidenum">
               <a:rPr lang="en-GB" smtClean="0"/>
               <a:t>4</a:t>
             </a:fld>
@@ -1705,7 +1705,7 @@
     </p:spTree>
     <p:extLst>
       <p:ext uri="{BB962C8B-B14F-4D97-AF65-F5344CB8AC3E}">
-        <p14:creationId xmlns:p14="http://schemas.microsoft.com/office/powerpoint/2010/main" val="3759078560"/>
+        <p14:creationId xmlns:p14="http://schemas.microsoft.com/office/powerpoint/2010/main" val="3517338080"/>
       </p:ext>
     </p:extLst>
   </p:cSld>
@@ -1782,7 +1782,7 @@
           <a:bodyPr/>
           <a:lstStyle/>
           <a:p>
-            <a:fld id="{AEEF2A5A-C802-40EB-AFC1-120433C5638E}" type="slidenum">
+            <a:fld id="{51E82CE5-2603-479C-AEDC-E30E28585A01}" type="slidenum">
               <a:rPr lang="en-GB" smtClean="0"/>
               <a:t>5</a:t>
             </a:fld>
@@ -1793,7 +1793,7 @@
     </p:spTree>
     <p:extLst>
       <p:ext uri="{BB962C8B-B14F-4D97-AF65-F5344CB8AC3E}">
-        <p14:creationId xmlns:p14="http://schemas.microsoft.com/office/powerpoint/2010/main" val="2201818388"/>
+        <p14:creationId xmlns:p14="http://schemas.microsoft.com/office/powerpoint/2010/main" val="3747903118"/>
       </p:ext>
     </p:extLst>
   </p:cSld>
@@ -1870,7 +1870,7 @@
           <a:bodyPr/>
           <a:lstStyle/>
           <a:p>
-            <a:fld id="{AEEF2A5A-C802-40EB-AFC1-120433C5638E}" type="slidenum">
+            <a:fld id="{51E82CE5-2603-479C-AEDC-E30E28585A01}" type="slidenum">
               <a:rPr lang="en-GB" smtClean="0"/>
               <a:t>6</a:t>
             </a:fld>
@@ -1881,7 +1881,7 @@
     </p:spTree>
     <p:extLst>
       <p:ext uri="{BB962C8B-B14F-4D97-AF65-F5344CB8AC3E}">
-        <p14:creationId xmlns:p14="http://schemas.microsoft.com/office/powerpoint/2010/main" val="968738501"/>
+        <p14:creationId xmlns:p14="http://schemas.microsoft.com/office/powerpoint/2010/main" val="2869246211"/>
       </p:ext>
     </p:extLst>
   </p:cSld>
@@ -1958,7 +1958,7 @@
           <a:bodyPr/>
           <a:lstStyle/>
           <a:p>
-            <a:fld id="{AEEF2A5A-C802-40EB-AFC1-120433C5638E}" type="slidenum">
+            <a:fld id="{51E82CE5-2603-479C-AEDC-E30E28585A01}" type="slidenum">
               <a:rPr lang="en-GB" smtClean="0"/>
               <a:t>7</a:t>
             </a:fld>
@@ -1969,7 +1969,7 @@
     </p:spTree>
     <p:extLst>
       <p:ext uri="{BB962C8B-B14F-4D97-AF65-F5344CB8AC3E}">
-        <p14:creationId xmlns:p14="http://schemas.microsoft.com/office/powerpoint/2010/main" val="765445936"/>
+        <p14:creationId xmlns:p14="http://schemas.microsoft.com/office/powerpoint/2010/main" val="2363056413"/>
       </p:ext>
     </p:extLst>
   </p:cSld>
@@ -2025,7 +2025,7 @@
           <a:p>
             <a:r>
               <a:rPr lang="vi-VN"/>
-              <a:t>Phần phân tích yêu cầu: 33 yêu cầu chức năng chia năm nhóm, 13 yêu cầu phi chức năng đều có tiêu chí đo hoặc cách kiểm chứng, 19 ca sử dụng, 10 quy tắc nghiệp vụ, 5 tác nhân gồm Khách, Độc giả, Thủ thư, Quản trị viên và hệ thống bên ngoài cùng tác vụ định kỳ. Cơ sở dữ liệu có 18 bảng. Điểm em muốn nhấn mạnh là tính truy vết: từ vấn đề tới yêu cầu, từ yêu cầu tới ca sử dụng qua ma trận truy vết, và từ ca sử dụng tới kết quả kiểm thử.</a:t>
+              <a:t>Phần phân tích yêu cầu: 33 yêu cầu chức năng chia năm nhóm, 13 yêu cầu phi chức năng đều có tiêu chí đo hoặc cách kiểm chứng, 19 ca sử dụng, 11 quy tắc nghiệp vụ, 5 tác nhân gồm Khách, Độc giả, Thủ thư, Quản trị viên và hệ thống bên ngoài cùng tác vụ định kỳ. Cơ sở dữ liệu có 18 bảng. Điểm em muốn nhấn mạnh là tính truy vết: từ vấn đề tới yêu cầu, từ yêu cầu tới ca sử dụng qua ma trận truy vết, và từ ca sử dụng tới kết quả kiểm thử.</a:t>
             </a:r>
             <a:endParaRPr lang="en-GB"/>
           </a:p>
@@ -2046,7 +2046,7 @@
           <a:bodyPr/>
           <a:lstStyle/>
           <a:p>
-            <a:fld id="{AEEF2A5A-C802-40EB-AFC1-120433C5638E}" type="slidenum">
+            <a:fld id="{51E82CE5-2603-479C-AEDC-E30E28585A01}" type="slidenum">
               <a:rPr lang="en-GB" smtClean="0"/>
               <a:t>8</a:t>
             </a:fld>
@@ -2057,7 +2057,7 @@
     </p:spTree>
     <p:extLst>
       <p:ext uri="{BB962C8B-B14F-4D97-AF65-F5344CB8AC3E}">
-        <p14:creationId xmlns:p14="http://schemas.microsoft.com/office/powerpoint/2010/main" val="1073067317"/>
+        <p14:creationId xmlns:p14="http://schemas.microsoft.com/office/powerpoint/2010/main" val="3099840510"/>
       </p:ext>
     </p:extLst>
   </p:cSld>
@@ -2134,7 +2134,7 @@
           <a:bodyPr/>
           <a:lstStyle/>
           <a:p>
-            <a:fld id="{AEEF2A5A-C802-40EB-AFC1-120433C5638E}" type="slidenum">
+            <a:fld id="{51E82CE5-2603-479C-AEDC-E30E28585A01}" type="slidenum">
               <a:rPr lang="en-GB" smtClean="0"/>
               <a:t>9</a:t>
             </a:fld>
@@ -2145,7 +2145,7 @@
     </p:spTree>
     <p:extLst>
       <p:ext uri="{BB962C8B-B14F-4D97-AF65-F5344CB8AC3E}">
-        <p14:creationId xmlns:p14="http://schemas.microsoft.com/office/powerpoint/2010/main" val="2014276044"/>
+        <p14:creationId xmlns:p14="http://schemas.microsoft.com/office/powerpoint/2010/main" val="893767429"/>
       </p:ext>
     </p:extLst>
   </p:cSld>
@@ -8923,7 +8923,7 @@
                 <a:latin typeface="Times New Roman"/>
                 <a:cs typeface="Times New Roman"/>
               </a:rPr>
-              <a:t>50/55</a:t>
+              <a:t>55/55</a:t>
             </a:r>
           </a:p>
         </p:txBody>
@@ -8970,7 +8970,7 @@
                 <a:latin typeface="Times New Roman"/>
                 <a:cs typeface="Times New Roman"/>
               </a:rPr>
-              <a:t>ca kiểm thử chức năng đạt</a:t>
+              <a:t>ca kiểm thử chức năng đạt ở lần chạy cuối</a:t>
             </a:r>
           </a:p>
         </p:txBody>
@@ -9560,7 +9560,7 @@
                 <a:latin typeface="Times New Roman"/>
                 <a:cs typeface="Times New Roman"/>
               </a:rPr>
-              <a:t>Kịch bản Python gọi REST API trên hệ thống Docker cục bộ, lưu kết quả từng ca dạng JSON. Lần chạy đầu đạt 48/55 ca; chạy lại sau khắc phục đạt 50/55 ca.</a:t>
+              <a:t>Kịch bản Python gọi REST API trên hệ thống Docker cục bộ, lưu kết quả từng ca dạng JSON. Lần chạy đầu 48/55; sau khắc phục bảo mật 50/55; sau khắc phục 5 lỗi còn lại 55/55.</a:t>
             </a:r>
           </a:p>
         </p:txBody>
@@ -10650,7 +10650,7 @@
                 <a:latin typeface="Times New Roman"/>
                 <a:cs typeface="Times New Roman"/>
               </a:rPr>
-              <a:t>HẠN CHẾ CÒN LẠI</a:t>
+              <a:t>KHẮC PHỤC &amp; HẠN CHẾ</a:t>
             </a:r>
           </a:p>
         </p:txBody>
@@ -10697,7 +10697,7 @@
                 <a:latin typeface="Times New Roman"/>
                 <a:cs typeface="Times New Roman"/>
               </a:rPr>
-              <a:t>Các lỗi còn lại đều nhỏ và đã có hướng khắc phục rõ</a:t>
+              <a:t>Năm lỗi phát hiện khi kiểm thử đã được khắc phục; còn lại là hạn chế về phạm vi</a:t>
             </a:r>
           </a:p>
         </p:txBody>
@@ -10775,7 +10775,7 @@
                 <a:latin typeface="Times New Roman"/>
                 <a:cs typeface="Times New Roman"/>
               </a:rPr>
-              <a:t>5 ca kiểm thử chưa đạt</a:t>
+              <a:t>5 lỗi đã khắc phục sau kiểm thử</a:t>
             </a:r>
           </a:p>
         </p:txBody>
@@ -10853,7 +10853,7 @@
                 <a:latin typeface="Times New Roman"/>
                 <a:cs typeface="Times New Roman"/>
               </a:rPr>
-              <a:t>Phạm vi và triển khai</a:t>
+              <a:t>Hạn chế về phạm vi</a:t>
             </a:r>
           </a:p>
         </p:txBody>
@@ -10951,7 +10951,7 @@
                 <a:latin typeface="Times New Roman"/>
                 <a:cs typeface="Times New Roman"/>
               </a:rPr>
-              <a:t>Thủ thư đọc được cấu hình hệ thống</a:t>
+              <a:t>Cấu hình hệ thống: chỉ Quản trị viên</a:t>
             </a:r>
           </a:p>
         </p:txBody>
@@ -11049,7 +11049,7 @@
                 <a:latin typeface="Times New Roman"/>
                 <a:cs typeface="Times New Roman"/>
               </a:rPr>
-              <a:t>Sách ẩn vẫn lộ qua API công khai</a:t>
+              <a:t>API công khai luôn ẩn sách bị ẩn</a:t>
             </a:r>
           </a:p>
         </p:txBody>
@@ -11147,7 +11147,7 @@
                 <a:latin typeface="Times New Roman"/>
                 <a:cs typeface="Times New Roman"/>
               </a:rPr>
-              <a:t>API chưa giới hạn thời hạn mượn</a:t>
+              <a:t>Thời hạn mượn tối đa 30 ngày (BR-11)</a:t>
             </a:r>
           </a:p>
         </p:txBody>
@@ -11245,7 +11245,7 @@
                 <a:latin typeface="Times New Roman"/>
                 <a:cs typeface="Times New Roman"/>
               </a:rPr>
-              <a:t>Đặt trước chưa chuyển sang hoàn tất</a:t>
+              <a:t>Đặt trước chuyển hoàn tất khi đã mượn</a:t>
             </a:r>
           </a:p>
         </p:txBody>
@@ -11343,7 +11343,7 @@
                 <a:latin typeface="Times New Roman"/>
                 <a:cs typeface="Times New Roman"/>
               </a:rPr>
-              <a:t>Chưa cập nhật số bản mất, hỏng khi trả</a:t>
+              <a:t>Cập nhật số bản mất, hỏng khi trả</a:t>
             </a:r>
           </a:p>
         </p:txBody>
@@ -11454,6 +11454,34 @@
                 <a:cs typeface="Times New Roman"/>
               </a:rPr>
               <a:t>Chưa kiểm thử tự động giao diện, chưa thử trên Firefox và điện thoại</a:t>
+            </a:r>
+          </a:p>
+          <a:p>
+            <a:pPr marL="285750" indent="-285750" algn="l">
+              <a:lnSpc>
+                <a:spcPct val="105000"/>
+              </a:lnSpc>
+              <a:spcBef>
+                <a:spcPts val="1000"/>
+              </a:spcBef>
+              <a:spcAft>
+                <a:spcPts val="0"/>
+              </a:spcAft>
+              <a:buClr>
+                <a:srgbClr val="F26522"/>
+              </a:buClr>
+              <a:buFont typeface="Arial"/>
+              <a:buChar char="•"/>
+            </a:pPr>
+            <a:r>
+              <a:rPr lang="vi-VN" sz="1700" b="0" i="0" dirty="0">
+                <a:solidFill>
+                  <a:srgbClr val="1F2433"/>
+                </a:solidFill>
+                <a:latin typeface="Times New Roman"/>
+                <a:cs typeface="Times New Roman"/>
+              </a:rPr>
+              <a:t>Ngày mượn trong quá khứ mới được chặn ở giao diện</a:t>
             </a:r>
           </a:p>
         </p:txBody>
@@ -13220,7 +13248,7 @@
                 <a:latin typeface="Times New Roman"/>
                 <a:cs typeface="Times New Roman"/>
               </a:rPr>
-              <a:t>Kiểm thử: 50/55 chức năng, 7/7 bảo mật, 5/5 hiệu năng</a:t>
+              <a:t>Kiểm thử: 55/55 chức năng, 7/7 bảo mật, 5/5 hiệu năng</a:t>
             </a:r>
           </a:p>
           <a:p>
@@ -13248,7 +13276,7 @@
                 <a:latin typeface="Times New Roman"/>
                 <a:cs typeface="Times New Roman"/>
               </a:rPr>
-              <a:t>Phát hiện và khắc phục 6 khiếm khuyết bảo mật, có kiểm chứng</a:t>
+              <a:t>Phát hiện và khắc phục 6 khiếm khuyết bảo mật và 5 lỗi nghiệp vụ</a:t>
             </a:r>
           </a:p>
         </p:txBody>
@@ -13380,7 +13408,7 @@
                 <a:latin typeface="Times New Roman"/>
                 <a:cs typeface="Times New Roman"/>
               </a:rPr>
-              <a:t>Sửa 5 lỗi còn lại: TC-13, 18, 26, 37, 44</a:t>
+              <a:t>Bổ sung giao diện đăng nhập Google và trang quên mật khẩu</a:t>
             </a:r>
           </a:p>
           <a:p>
@@ -13408,7 +13436,7 @@
                 <a:latin typeface="Times New Roman"/>
                 <a:cs typeface="Times New Roman"/>
               </a:rPr>
-              <a:t>Bổ sung giao diện đăng nhập Google và trang quên mật khẩu</a:t>
+              <a:t>Chặn ngày mượn trong quá khứ ở cả máy chủ</a:t>
             </a:r>
           </a:p>
           <a:p>
@@ -20545,7 +20573,7 @@
                 <a:latin typeface="Times New Roman"/>
                 <a:cs typeface="Times New Roman"/>
               </a:rPr>
-              <a:t>10</a:t>
+              <a:t>11</a:t>
             </a:r>
           </a:p>
         </p:txBody>

</xml_diff>